<commit_message>
Refactor planner module and update related imports; add new PPT planner functionality
- Updated import paths for plan_presentation from agents.planner to agents.ppt_planner.
- Enhanced map_slides_to_tasks function to include total_pages parameter in slide state initialization.
- Modified generate_slide_svg_node to retrieve total_pages from SlideState.
- Introduced new ppt_planner module with functions for extracting content and planning slides.
- Created prompts for main content extraction and slide planning.
- Added SVG validation and finalization utilities for improved SVG handling.
- Implemented a PPTX merger utility for combining SVG files into a PPTX presentation.
- Established new slide_composer and slide_reviewer modules for slide generation and review processes.
</commit_message>
<xml_diff>
--- a/test/test_composer_output/slide_04.pptx
+++ b/test/test_composer_output/slide_04.pptx
@@ -3197,47 +3197,7 @@
       </p:sp>
       <p:sp>
         <p:nvSpPr>
-          <p:cNvPr id="4" name="TextBox 4"/>
-          <p:cNvSpPr txBox="1"/>
-          <p:nvPr/>
-        </p:nvSpPr>
-        <p:spPr>
-          <a:xfrm>
-            <a:off x="746760" y="251460"/>
-            <a:ext cx="4244607" cy="243840"/>
-          </a:xfrm>
-          <a:prstGeom prst="rect">
-            <a:avLst/>
-          </a:prstGeom>
-          <a:noFill/>
-          <a:ln>
-            <a:noFill/>
-          </a:ln>
-        </p:spPr>
-        <p:txBody>
-          <a:bodyPr wrap="none" lIns="0" tIns="0" rIns="0" bIns="0" anchor="t" anchorCtr="0">
-            <a:spAutoFit/>
-          </a:bodyPr>
-          <a:lstStyle/>
-          <a:p>
-            <a:pPr algn="l"/>
-            <a:r>
-              <a:rPr lang="zh-CN" sz="1200" b="1" dirty="0">
-                <a:solidFill>
-                  <a:srgbClr val="003F87"/>
-                </a:solidFill>
-                <a:latin typeface="Arial"/>
-                <a:ea typeface="Microsoft YaHei"/>
-                <a:cs typeface="Arial"/>
-              </a:rPr>
-              <a:t>Technical Approach: Transformer Architecture</a:t>
-            </a:r>
-          </a:p>
-        </p:txBody>
-      </p:sp>
-      <p:sp>
-        <p:nvSpPr>
-          <p:cNvPr id="5" name="Line 5"/>
+          <p:cNvPr id="4" name="Line 4"/>
           <p:cNvSpPr/>
           <p:nvPr/>
         </p:nvSpPr>
@@ -3273,14 +3233,14 @@
       </p:sp>
       <p:sp>
         <p:nvSpPr>
-          <p:cNvPr id="6" name="TextBox 6"/>
+          <p:cNvPr id="5" name="TextBox 5"/>
           <p:cNvSpPr txBox="1"/>
           <p:nvPr/>
         </p:nvSpPr>
         <p:spPr>
           <a:xfrm>
-            <a:off x="937260" y="1394460"/>
-            <a:ext cx="11141964" cy="243840"/>
+            <a:off x="724852" y="65246"/>
+            <a:ext cx="10346229" cy="594360"/>
           </a:xfrm>
           <a:prstGeom prst="rect">
             <a:avLst/>
@@ -3298,29 +3258,29 @@
           <a:p>
             <a:pPr algn="l"/>
             <a:r>
-              <a:rPr lang="zh-CN" sz="1200" dirty="0">
+              <a:rPr lang="zh-CN" sz="2925" b="1" dirty="0">
                 <a:solidFill>
-                  <a:srgbClr val="333333"/>
+                  <a:srgbClr val="003F87"/>
                 </a:solidFill>
                 <a:latin typeface="Arial"/>
                 <a:ea typeface="Microsoft YaHei"/>
                 <a:cs typeface="Arial"/>
               </a:rPr>
-              <a:t>The Transformer consists of an encoder-decoder structure using stacked self-attention and point-wise, fully connected layers.</a:t>
-            </a:r>
-          </a:p>
-        </p:txBody>
-      </p:sp>
-      <p:sp>
-        <p:nvSpPr>
-          <p:cNvPr id="7" name="TextBox 7"/>
+              <a:t>Technical Approach: Transformer Architecture</a:t>
+            </a:r>
+          </a:p>
+        </p:txBody>
+      </p:sp>
+      <p:sp>
+        <p:nvSpPr>
+          <p:cNvPr id="6" name="TextBox 6"/>
           <p:cNvSpPr txBox="1"/>
           <p:nvPr/>
         </p:nvSpPr>
         <p:spPr>
           <a:xfrm>
-            <a:off x="937260" y="2346960"/>
-            <a:ext cx="10370820" cy="243840"/>
+            <a:off x="931545" y="1536382"/>
+            <a:ext cx="10572845" cy="335280"/>
           </a:xfrm>
           <a:prstGeom prst="rect">
             <a:avLst/>
@@ -3338,7 +3298,7 @@
           <a:p>
             <a:pPr algn="l"/>
             <a:r>
-              <a:rPr lang="zh-CN" sz="1200" dirty="0">
+              <a:rPr lang="zh-CN" sz="1650" dirty="0">
                 <a:solidFill>
                   <a:srgbClr val="333333"/>
                 </a:solidFill>
@@ -3346,21 +3306,21 @@
                 <a:ea typeface="Microsoft YaHei"/>
                 <a:cs typeface="Arial"/>
               </a:rPr>
-              <a:t>Key components include multi-head attention, scaled dot-product attention, and position-wise feed-forward networks.</a:t>
-            </a:r>
-          </a:p>
-        </p:txBody>
-      </p:sp>
-      <p:sp>
-        <p:nvSpPr>
-          <p:cNvPr id="8" name="TextBox 8"/>
+              <a:t>The Transformer consists of an encoder-decoder structure using stacked self-attention</a:t>
+            </a:r>
+          </a:p>
+        </p:txBody>
+      </p:sp>
+      <p:sp>
+        <p:nvSpPr>
+          <p:cNvPr id="7" name="TextBox 7"/>
           <p:cNvSpPr txBox="1"/>
           <p:nvPr/>
         </p:nvSpPr>
         <p:spPr>
           <a:xfrm>
-            <a:off x="937260" y="3299460"/>
-            <a:ext cx="5822823" cy="243840"/>
+            <a:off x="931545" y="1549718"/>
+            <a:ext cx="4716971" cy="335280"/>
           </a:xfrm>
           <a:prstGeom prst="rect">
             <a:avLst/>
@@ -3378,7 +3338,127 @@
           <a:p>
             <a:pPr algn="l"/>
             <a:r>
-              <a:rPr lang="zh-CN" sz="1200" dirty="0">
+              <a:rPr lang="zh-CN" sz="1650" dirty="0">
+                <a:solidFill>
+                  <a:srgbClr val="333333"/>
+                </a:solidFill>
+                <a:latin typeface="Arial"/>
+                <a:ea typeface="Microsoft YaHei"/>
+                <a:cs typeface="Arial"/>
+              </a:rPr>
+              <a:t>and point-wise, fully connected layers.</a:t>
+            </a:r>
+          </a:p>
+        </p:txBody>
+      </p:sp>
+      <p:sp>
+        <p:nvSpPr>
+          <p:cNvPr id="8" name="TextBox 8"/>
+          <p:cNvSpPr txBox="1"/>
+          <p:nvPr/>
+        </p:nvSpPr>
+        <p:spPr>
+          <a:xfrm>
+            <a:off x="931545" y="2298382"/>
+            <a:ext cx="9572768" cy="335280"/>
+          </a:xfrm>
+          <a:prstGeom prst="rect">
+            <a:avLst/>
+          </a:prstGeom>
+          <a:noFill/>
+          <a:ln>
+            <a:noFill/>
+          </a:ln>
+        </p:spPr>
+        <p:txBody>
+          <a:bodyPr wrap="none" lIns="0" tIns="0" rIns="0" bIns="0" anchor="t" anchorCtr="0">
+            <a:spAutoFit/>
+          </a:bodyPr>
+          <a:lstStyle/>
+          <a:p>
+            <a:pPr algn="l"/>
+            <a:r>
+              <a:rPr lang="zh-CN" sz="1650" dirty="0">
+                <a:solidFill>
+                  <a:srgbClr val="333333"/>
+                </a:solidFill>
+                <a:latin typeface="Arial"/>
+                <a:ea typeface="Microsoft YaHei"/>
+                <a:cs typeface="Arial"/>
+              </a:rPr>
+              <a:t>Key components include multi-head attention, scaled dot-product attention, and</a:t>
+            </a:r>
+          </a:p>
+        </p:txBody>
+      </p:sp>
+      <p:sp>
+        <p:nvSpPr>
+          <p:cNvPr id="9" name="TextBox 9"/>
+          <p:cNvSpPr txBox="1"/>
+          <p:nvPr/>
+        </p:nvSpPr>
+        <p:spPr>
+          <a:xfrm>
+            <a:off x="931545" y="2311718"/>
+            <a:ext cx="4656725" cy="335280"/>
+          </a:xfrm>
+          <a:prstGeom prst="rect">
+            <a:avLst/>
+          </a:prstGeom>
+          <a:noFill/>
+          <a:ln>
+            <a:noFill/>
+          </a:ln>
+        </p:spPr>
+        <p:txBody>
+          <a:bodyPr wrap="none" lIns="0" tIns="0" rIns="0" bIns="0" anchor="t" anchorCtr="0">
+            <a:spAutoFit/>
+          </a:bodyPr>
+          <a:lstStyle/>
+          <a:p>
+            <a:pPr algn="l"/>
+            <a:r>
+              <a:rPr lang="zh-CN" sz="1650" dirty="0">
+                <a:solidFill>
+                  <a:srgbClr val="333333"/>
+                </a:solidFill>
+                <a:latin typeface="Arial"/>
+                <a:ea typeface="Microsoft YaHei"/>
+                <a:cs typeface="Arial"/>
+              </a:rPr>
+              <a:t>position-wise feed-forward networks.</a:t>
+            </a:r>
+          </a:p>
+        </p:txBody>
+      </p:sp>
+      <p:sp>
+        <p:nvSpPr>
+          <p:cNvPr id="10" name="TextBox 10"/>
+          <p:cNvSpPr txBox="1"/>
+          <p:nvPr/>
+        </p:nvSpPr>
+        <p:spPr>
+          <a:xfrm>
+            <a:off x="931545" y="3250882"/>
+            <a:ext cx="8006382" cy="335280"/>
+          </a:xfrm>
+          <a:prstGeom prst="rect">
+            <a:avLst/>
+          </a:prstGeom>
+          <a:noFill/>
+          <a:ln>
+            <a:noFill/>
+          </a:ln>
+        </p:spPr>
+        <p:txBody>
+          <a:bodyPr wrap="none" lIns="0" tIns="0" rIns="0" bIns="0" anchor="t" anchorCtr="0">
+            <a:spAutoFit/>
+          </a:bodyPr>
+          <a:lstStyle/>
+          <a:p>
+            <a:pPr algn="l"/>
+            <a:r>
+              <a:rPr lang="zh-CN" sz="1650" dirty="0">
                 <a:solidFill>
                   <a:srgbClr val="333333"/>
                 </a:solidFill>
@@ -3393,7 +3473,7 @@
       </p:sp>
       <p:pic>
         <p:nvPicPr>
-          <p:cNvPr id="9" name="Image 9"/>
+          <p:cNvPr id="11" name="Image 11"/>
           <p:cNvPicPr>
             <a:picLocks noChangeAspect="1"/>
           </p:cNvPicPr>
@@ -3417,14 +3497,14 @@
       </p:pic>
       <p:sp>
         <p:nvSpPr>
-          <p:cNvPr id="10" name="TextBox 10"/>
+          <p:cNvPr id="12" name="TextBox 12"/>
           <p:cNvSpPr txBox="1"/>
           <p:nvPr/>
         </p:nvSpPr>
         <p:spPr>
           <a:xfrm>
-            <a:off x="7604760" y="4347210"/>
-            <a:ext cx="10607421" cy="243840"/>
+            <a:off x="7602855" y="4331018"/>
+            <a:ext cx="8404050" cy="274320"/>
           </a:xfrm>
           <a:prstGeom prst="rect">
             <a:avLst/>
@@ -3442,7 +3522,7 @@
           <a:p>
             <a:pPr algn="l"/>
             <a:r>
-              <a:rPr lang="zh-CN" sz="1200" dirty="0">
+              <a:rPr lang="zh-CN" sz="1350" dirty="0">
                 <a:solidFill>
                   <a:srgbClr val="666666"/>
                 </a:solidFill>
@@ -3450,21 +3530,21 @@
                 <a:ea typeface="Microsoft YaHei"/>
                 <a:cs typeface="Arial"/>
               </a:rPr>
-              <a:t>(left) Scaled Dot-Product Attention. (right) Multi-Head Attention consists of several attention layers running in parallel.</a:t>
-            </a:r>
-          </a:p>
-        </p:txBody>
-      </p:sp>
-      <p:sp>
-        <p:nvSpPr>
-          <p:cNvPr id="11" name="TextBox 11"/>
+              <a:t>(left) Scaled Dot-Product Attention. (right) Multi-Head Attention consists of several</a:t>
+            </a:r>
+          </a:p>
+        </p:txBody>
+      </p:sp>
+      <p:sp>
+        <p:nvSpPr>
+          <p:cNvPr id="13" name="TextBox 13"/>
           <p:cNvSpPr txBox="1"/>
           <p:nvPr/>
         </p:nvSpPr>
         <p:spPr>
           <a:xfrm>
-            <a:off x="10680954" y="6347460"/>
-            <a:ext cx="573786" cy="243840"/>
+            <a:off x="7602855" y="4344352"/>
+            <a:ext cx="3504438" cy="274320"/>
           </a:xfrm>
           <a:prstGeom prst="rect">
             <a:avLst/>
@@ -3480,9 +3560,49 @@
           </a:bodyPr>
           <a:lstStyle/>
           <a:p>
+            <a:pPr algn="l"/>
+            <a:r>
+              <a:rPr lang="zh-CN" sz="1350" dirty="0">
+                <a:solidFill>
+                  <a:srgbClr val="666666"/>
+                </a:solidFill>
+                <a:latin typeface="Arial"/>
+                <a:ea typeface="Microsoft YaHei"/>
+                <a:cs typeface="Arial"/>
+              </a:rPr>
+              <a:t>attention layers running in parallel.</a:t>
+            </a:r>
+          </a:p>
+        </p:txBody>
+      </p:sp>
+      <p:sp>
+        <p:nvSpPr>
+          <p:cNvPr id="14" name="TextBox 14"/>
+          <p:cNvSpPr txBox="1"/>
+          <p:nvPr/>
+        </p:nvSpPr>
+        <p:spPr>
+          <a:xfrm>
+            <a:off x="11141821" y="6363652"/>
+            <a:ext cx="111014" cy="213360"/>
+          </a:xfrm>
+          <a:prstGeom prst="rect">
+            <a:avLst/>
+          </a:prstGeom>
+          <a:noFill/>
+          <a:ln>
+            <a:noFill/>
+          </a:ln>
+        </p:spPr>
+        <p:txBody>
+          <a:bodyPr wrap="none" lIns="0" tIns="0" rIns="0" bIns="0" anchor="t" anchorCtr="0">
+            <a:spAutoFit/>
+          </a:bodyPr>
+          <a:lstStyle/>
+          <a:p>
             <a:pPr algn="r"/>
             <a:r>
-              <a:rPr lang="zh-CN" sz="1200" dirty="0">
+              <a:rPr lang="zh-CN" sz="1050" dirty="0">
                 <a:solidFill>
                   <a:srgbClr val="999999"/>
                 </a:solidFill>
@@ -3490,7 +3610,7 @@
                 <a:ea typeface="Microsoft YaHei"/>
                 <a:cs typeface="Arial"/>
               </a:rPr>
-              <a:t>04 / 12</a:t>
+              <a:t>4</a:t>
             </a:r>
           </a:p>
         </p:txBody>

</xml_diff>